<commit_message>
documentation + ppt fixes
</commit_message>
<xml_diff>
--- a/automate_ppt.pptx
+++ b/automate_ppt.pptx
@@ -119,6 +119,11 @@
       </a:defRPr>
     </a:lvl9pPr>
   </p:defaultTextStyle>
+  <p:extLst>
+    <p:ext uri="{EFAFB233-063F-42B5-8137-9DF3F51BA10A}">
+      <p15:sldGuideLst xmlns:p15="http://schemas.microsoft.com/office/powerpoint/2012/main"/>
+    </p:ext>
+  </p:extLst>
 </p:presentation>
 </file>
 
@@ -221,7 +226,7 @@
           </a:lstStyle>
           <a:p>
             <a:fld id="{AAFAE474-339D-4E5C-9F56-CCA657A6D678}" type="datetimeFigureOut">
-              <a:t>2026. 04. 16.</a:t>
+              <a:t>2026. 04. 23.</a:t>
             </a:fld>
             <a:endParaRPr lang="en-US"/>
           </a:p>
@@ -533,7 +538,7 @@
           <a:p>
             <a:r>
               <a:rPr lang="hu-HU" dirty="0"/>
-              <a:t>Jó napot kívánunk!</a:t>
+              <a:t>Köszöntünk mindenkit!</a:t>
             </a:r>
           </a:p>
           <a:p>
@@ -553,7 +558,7 @@
           <a:p>
             <a:r>
               <a:rPr lang="hu-HU" dirty="0"/>
-              <a:t>A bemutató során ismertetjük a weboldal célját, a fejlesztés és tervezés menetét, és a munkamegosztást. Ezután használat közben is bemutatjuk a weboldalunkat.</a:t>
+              <a:t>A bemutató során végig megyünk a tervezési és fejlesztési folyamaton, majd használat közben is bemutatjuk a weboldalunkat.</a:t>
             </a:r>
           </a:p>
         </p:txBody>
@@ -645,22 +650,436 @@
           </a:p>
           <a:p>
             <a:r>
+              <a:rPr lang="hu-HU" dirty="0" err="1"/>
+              <a:t>All</a:t>
+            </a:r>
+            <a:r>
               <a:rPr lang="hu-HU" dirty="0"/>
-              <a:t>Összegezve minden tervet megvalósítottunk, és még túl is szárnyaltuk magunkat, mivel a tervezettnél még több funkciót sikerült implementálnunk. Voltak </a:t>
+              <a:t> in </a:t>
             </a:r>
             <a:r>
               <a:rPr lang="hu-HU" dirty="0" err="1"/>
-              <a:t>kiseb</a:t>
+              <a:t>all</a:t>
             </a:r>
             <a:r>
               <a:rPr lang="hu-HU" dirty="0"/>
-              <a:t>-nagyobb változtatások </a:t>
-            </a:r>
-          </a:p>
-          <a:p>
+              <a:t> </a:t>
+            </a:r>
+            <a:r>
+              <a:rPr lang="hu-HU" dirty="0" err="1"/>
+              <a:t>we</a:t>
+            </a:r>
             <a:r>
               <a:rPr lang="hu-HU" dirty="0"/>
-              <a:t>designban, működésben, kialakításban, de ezek mind csak jobbá tették az oldalt. Sikerült felhasználóbaráttá alakítani az oldalt és a fejlesztés során elsajátítottuk a használt technológiákat.</a:t>
+              <a:t> </a:t>
+            </a:r>
+            <a:r>
+              <a:rPr lang="hu-HU" dirty="0" err="1"/>
+              <a:t>have</a:t>
+            </a:r>
+            <a:r>
+              <a:rPr lang="hu-HU" dirty="0"/>
+              <a:t> </a:t>
+            </a:r>
+            <a:r>
+              <a:rPr lang="hu-HU" dirty="0" err="1"/>
+              <a:t>managed</a:t>
+            </a:r>
+            <a:r>
+              <a:rPr lang="hu-HU" dirty="0"/>
+              <a:t> </a:t>
+            </a:r>
+            <a:r>
+              <a:rPr lang="hu-HU" dirty="0" err="1"/>
+              <a:t>to</a:t>
+            </a:r>
+            <a:r>
+              <a:rPr lang="hu-HU" dirty="0"/>
+              <a:t> </a:t>
+            </a:r>
+            <a:r>
+              <a:rPr lang="hu-HU" dirty="0" err="1"/>
+              <a:t>finish</a:t>
+            </a:r>
+            <a:r>
+              <a:rPr lang="hu-HU" dirty="0"/>
+              <a:t> </a:t>
+            </a:r>
+            <a:r>
+              <a:rPr lang="hu-HU" dirty="0" err="1"/>
+              <a:t>all</a:t>
+            </a:r>
+            <a:r>
+              <a:rPr lang="hu-HU" dirty="0"/>
+              <a:t> of </a:t>
+            </a:r>
+            <a:r>
+              <a:rPr lang="hu-HU" dirty="0" err="1"/>
+              <a:t>our</a:t>
+            </a:r>
+            <a:r>
+              <a:rPr lang="hu-HU" dirty="0"/>
+              <a:t> </a:t>
+            </a:r>
+            <a:r>
+              <a:rPr lang="hu-HU" dirty="0" err="1"/>
+              <a:t>plans</a:t>
+            </a:r>
+            <a:r>
+              <a:rPr lang="hu-HU" dirty="0"/>
+              <a:t>. </a:t>
+            </a:r>
+          </a:p>
+          <a:p>
+            <a:r>
+              <a:rPr lang="hu-HU" dirty="0" err="1"/>
+              <a:t>Furthermore</a:t>
+            </a:r>
+            <a:r>
+              <a:rPr lang="hu-HU" dirty="0"/>
+              <a:t> </a:t>
+            </a:r>
+            <a:r>
+              <a:rPr lang="hu-HU" dirty="0" err="1"/>
+              <a:t>we</a:t>
+            </a:r>
+            <a:r>
+              <a:rPr lang="hu-HU" dirty="0"/>
+              <a:t> </a:t>
+            </a:r>
+            <a:r>
+              <a:rPr lang="hu-HU" dirty="0" err="1"/>
+              <a:t>have</a:t>
+            </a:r>
+            <a:r>
+              <a:rPr lang="hu-HU" dirty="0"/>
+              <a:t> </a:t>
+            </a:r>
+            <a:r>
+              <a:rPr lang="hu-HU" dirty="0" err="1"/>
+              <a:t>implemented</a:t>
+            </a:r>
+            <a:r>
+              <a:rPr lang="hu-HU" dirty="0"/>
+              <a:t> </a:t>
+            </a:r>
+            <a:r>
+              <a:rPr lang="hu-HU" dirty="0" err="1"/>
+              <a:t>even</a:t>
+            </a:r>
+            <a:r>
+              <a:rPr lang="hu-HU" dirty="0"/>
+              <a:t> more </a:t>
+            </a:r>
+            <a:r>
+              <a:rPr lang="hu-HU" dirty="0" err="1"/>
+              <a:t>functions</a:t>
+            </a:r>
+            <a:r>
+              <a:rPr lang="hu-HU" dirty="0"/>
+              <a:t>.</a:t>
+            </a:r>
+          </a:p>
+          <a:p>
+            <a:r>
+              <a:rPr lang="hu-HU" dirty="0" err="1"/>
+              <a:t>We</a:t>
+            </a:r>
+            <a:r>
+              <a:rPr lang="hu-HU" dirty="0"/>
+              <a:t> had </a:t>
+            </a:r>
+            <a:r>
+              <a:rPr lang="hu-HU" dirty="0" err="1"/>
+              <a:t>to</a:t>
+            </a:r>
+            <a:r>
+              <a:rPr lang="hu-HU" dirty="0"/>
+              <a:t> </a:t>
+            </a:r>
+            <a:r>
+              <a:rPr lang="hu-HU" dirty="0" err="1"/>
+              <a:t>make</a:t>
+            </a:r>
+            <a:r>
+              <a:rPr lang="hu-HU" dirty="0"/>
+              <a:t> </a:t>
+            </a:r>
+            <a:r>
+              <a:rPr lang="hu-HU" dirty="0" err="1"/>
+              <a:t>some</a:t>
+            </a:r>
+            <a:r>
+              <a:rPr lang="hu-HU" dirty="0"/>
+              <a:t> </a:t>
+            </a:r>
+            <a:r>
+              <a:rPr lang="hu-HU" dirty="0" err="1"/>
+              <a:t>changes</a:t>
+            </a:r>
+            <a:r>
+              <a:rPr lang="hu-HU" dirty="0"/>
+              <a:t>, </a:t>
+            </a:r>
+            <a:r>
+              <a:rPr lang="hu-HU" dirty="0" err="1"/>
+              <a:t>for</a:t>
+            </a:r>
+            <a:r>
+              <a:rPr lang="hu-HU" dirty="0"/>
+              <a:t> </a:t>
+            </a:r>
+            <a:r>
+              <a:rPr lang="hu-HU" dirty="0" err="1"/>
+              <a:t>example</a:t>
+            </a:r>
+            <a:r>
+              <a:rPr lang="hu-HU" dirty="0"/>
+              <a:t> in </a:t>
+            </a:r>
+            <a:r>
+              <a:rPr lang="hu-HU" dirty="0" err="1"/>
+              <a:t>user</a:t>
+            </a:r>
+            <a:r>
+              <a:rPr lang="hu-HU" dirty="0"/>
+              <a:t> </a:t>
+            </a:r>
+            <a:r>
+              <a:rPr lang="hu-HU" dirty="0" err="1"/>
+              <a:t>interface</a:t>
+            </a:r>
+            <a:r>
+              <a:rPr lang="hu-HU" dirty="0"/>
+              <a:t>, </a:t>
+            </a:r>
+            <a:r>
+              <a:rPr lang="hu-HU" dirty="0" err="1"/>
+              <a:t>functionality</a:t>
+            </a:r>
+            <a:r>
+              <a:rPr lang="hu-HU" dirty="0"/>
+              <a:t>, design, </a:t>
+            </a:r>
+            <a:r>
+              <a:rPr lang="hu-HU" dirty="0" err="1"/>
+              <a:t>but</a:t>
+            </a:r>
+            <a:r>
+              <a:rPr lang="hu-HU" dirty="0"/>
+              <a:t> </a:t>
+            </a:r>
+            <a:r>
+              <a:rPr lang="hu-HU" dirty="0" err="1"/>
+              <a:t>the</a:t>
+            </a:r>
+            <a:r>
+              <a:rPr lang="hu-HU" dirty="0"/>
+              <a:t> website </a:t>
+            </a:r>
+            <a:r>
+              <a:rPr lang="hu-HU" dirty="0" err="1"/>
+              <a:t>turned</a:t>
+            </a:r>
+            <a:r>
+              <a:rPr lang="hu-HU" dirty="0"/>
+              <a:t> out </a:t>
+            </a:r>
+            <a:r>
+              <a:rPr lang="hu-HU" dirty="0" err="1"/>
+              <a:t>even</a:t>
+            </a:r>
+            <a:r>
+              <a:rPr lang="hu-HU" dirty="0"/>
+              <a:t> </a:t>
+            </a:r>
+            <a:r>
+              <a:rPr lang="hu-HU" dirty="0" err="1"/>
+              <a:t>better</a:t>
+            </a:r>
+            <a:r>
+              <a:rPr lang="hu-HU" dirty="0"/>
+              <a:t>.</a:t>
+            </a:r>
+          </a:p>
+          <a:p>
+            <a:r>
+              <a:rPr lang="hu-HU" dirty="0" err="1"/>
+              <a:t>We</a:t>
+            </a:r>
+            <a:r>
+              <a:rPr lang="hu-HU" dirty="0"/>
+              <a:t> </a:t>
+            </a:r>
+            <a:r>
+              <a:rPr lang="hu-HU" dirty="0" err="1"/>
+              <a:t>made</a:t>
+            </a:r>
+            <a:r>
+              <a:rPr lang="hu-HU" dirty="0"/>
+              <a:t> </a:t>
+            </a:r>
+            <a:r>
+              <a:rPr lang="hu-HU" dirty="0" err="1"/>
+              <a:t>the</a:t>
+            </a:r>
+            <a:r>
+              <a:rPr lang="hu-HU" dirty="0"/>
+              <a:t> website </a:t>
+            </a:r>
+            <a:r>
+              <a:rPr lang="hu-HU" dirty="0" err="1"/>
+              <a:t>as</a:t>
+            </a:r>
+            <a:r>
+              <a:rPr lang="hu-HU" dirty="0"/>
+              <a:t> </a:t>
+            </a:r>
+            <a:r>
+              <a:rPr lang="hu-HU" dirty="0" err="1"/>
+              <a:t>user</a:t>
+            </a:r>
+            <a:r>
+              <a:rPr lang="hu-HU" dirty="0"/>
+              <a:t> </a:t>
+            </a:r>
+            <a:r>
+              <a:rPr lang="hu-HU" dirty="0" err="1"/>
+              <a:t>friendly</a:t>
+            </a:r>
+            <a:r>
+              <a:rPr lang="hu-HU" dirty="0"/>
+              <a:t> </a:t>
+            </a:r>
+            <a:r>
+              <a:rPr lang="hu-HU" dirty="0" err="1"/>
+              <a:t>as</a:t>
+            </a:r>
+            <a:r>
+              <a:rPr lang="hu-HU" dirty="0"/>
+              <a:t> </a:t>
+            </a:r>
+            <a:r>
+              <a:rPr lang="hu-HU" dirty="0" err="1"/>
+              <a:t>we</a:t>
+            </a:r>
+            <a:r>
+              <a:rPr lang="hu-HU" dirty="0"/>
+              <a:t> </a:t>
+            </a:r>
+            <a:r>
+              <a:rPr lang="hu-HU" dirty="0" err="1"/>
+              <a:t>could</a:t>
+            </a:r>
+            <a:r>
+              <a:rPr lang="hu-HU" dirty="0"/>
+              <a:t> </a:t>
+            </a:r>
+            <a:r>
+              <a:rPr lang="hu-HU" dirty="0" err="1"/>
+              <a:t>through</a:t>
+            </a:r>
+            <a:r>
+              <a:rPr lang="hu-HU" dirty="0"/>
+              <a:t> </a:t>
+            </a:r>
+            <a:r>
+              <a:rPr lang="hu-HU" dirty="0" err="1"/>
+              <a:t>errorhandling</a:t>
+            </a:r>
+            <a:r>
+              <a:rPr lang="hu-HU" dirty="0"/>
+              <a:t> and </a:t>
+            </a:r>
+            <a:r>
+              <a:rPr lang="hu-HU" dirty="0" err="1"/>
+              <a:t>feedbacks</a:t>
+            </a:r>
+            <a:r>
+              <a:rPr lang="hu-HU" dirty="0"/>
+              <a:t>.</a:t>
+            </a:r>
+          </a:p>
+          <a:p>
+            <a:r>
+              <a:rPr lang="hu-HU" dirty="0" err="1"/>
+              <a:t>We</a:t>
+            </a:r>
+            <a:r>
+              <a:rPr lang="hu-HU" dirty="0"/>
+              <a:t> </a:t>
+            </a:r>
+            <a:r>
+              <a:rPr lang="hu-HU" dirty="0" err="1"/>
+              <a:t>have</a:t>
+            </a:r>
+            <a:r>
+              <a:rPr lang="hu-HU" dirty="0"/>
+              <a:t> </a:t>
+            </a:r>
+            <a:r>
+              <a:rPr lang="hu-HU" dirty="0" err="1"/>
+              <a:t>also</a:t>
+            </a:r>
+            <a:r>
+              <a:rPr lang="hu-HU" dirty="0"/>
+              <a:t> </a:t>
+            </a:r>
+            <a:r>
+              <a:rPr lang="hu-HU" dirty="0" err="1"/>
+              <a:t>mastered</a:t>
+            </a:r>
+            <a:r>
+              <a:rPr lang="hu-HU" dirty="0"/>
+              <a:t> </a:t>
+            </a:r>
+            <a:r>
+              <a:rPr lang="hu-HU" dirty="0" err="1"/>
+              <a:t>all</a:t>
+            </a:r>
+            <a:r>
+              <a:rPr lang="hu-HU" dirty="0"/>
+              <a:t> of </a:t>
+            </a:r>
+            <a:r>
+              <a:rPr lang="hu-HU" dirty="0" err="1"/>
+              <a:t>the</a:t>
+            </a:r>
+            <a:r>
+              <a:rPr lang="hu-HU" dirty="0"/>
+              <a:t> </a:t>
+            </a:r>
+            <a:r>
+              <a:rPr lang="hu-HU" dirty="0" err="1"/>
+              <a:t>used</a:t>
+            </a:r>
+            <a:r>
+              <a:rPr lang="hu-HU" dirty="0"/>
+              <a:t> </a:t>
+            </a:r>
+            <a:r>
+              <a:rPr lang="hu-HU" dirty="0" err="1"/>
+              <a:t>technologies</a:t>
+            </a:r>
+            <a:r>
+              <a:rPr lang="hu-HU" dirty="0"/>
+              <a:t> </a:t>
+            </a:r>
+            <a:r>
+              <a:rPr lang="hu-HU" dirty="0" err="1"/>
+              <a:t>during</a:t>
+            </a:r>
+            <a:r>
+              <a:rPr lang="hu-HU" dirty="0"/>
+              <a:t> </a:t>
+            </a:r>
+            <a:r>
+              <a:rPr lang="hu-HU" dirty="0" err="1"/>
+              <a:t>development</a:t>
+            </a:r>
+            <a:r>
+              <a:rPr lang="hu-HU"/>
+              <a:t>.</a:t>
             </a:r>
           </a:p>
           <a:p>
@@ -894,7 +1313,7 @@
           <a:p>
             <a:r>
               <a:rPr lang="hu-HU" dirty="0"/>
-              <a:t>A vezetés nem csak a közlekedésről szól, számos egyéb dologra kell figyelni. Például felírni, mennyit költünk tankolásra, megnézni milyen messzire megyünk, kiszámolni mennyi üzemanyagra lesz szükség, számon tartani a szervizeket, emlékeztetőket beállítani. Ezeket általában mind külön-külön helyeken tartjuk számon és ez összezavaró lehet. </a:t>
+              <a:t>Vezetés közben sok dologra kell figyelni. Például felírni, mennyit költünk tankolásra, megnézni milyen messzire megyünk, kiszámolni mennyi üzemanyagra lesz szükség, számon tartani a szervizeket, emlékeztetőket beállítani. Ezeket általában mind külön-külön helyeken tartjuk számon és ez összezavaró lehet. </a:t>
             </a:r>
           </a:p>
           <a:p>
@@ -1034,7 +1453,15 @@
           <a:p>
             <a:r>
               <a:rPr lang="hu-HU" dirty="0"/>
-              <a:t>A frontend részt én készítettem. Én feleltem a weboldal megjelenéséért. Az elkészítés során törekedtem arra hogy minél könnyebb legyen használni az oldalt, azaz elég visszajelzést adjon és egyértelmű legyen minden. Az oldalak közötti navigáció szintén hozzám tartozott, illetve a backenddel való összekötés, az onnan küldött adatok megjelenítése, grafikonok megjelenítése és az adatainak betöltése. A különböző hibákat szintén én irattam ki, és persze a frontend tesztelése is az én feladatom volt.</a:t>
+              <a:t>A frontend részt én készítettem. Én feleltem a weboldal megjelenéséért. Az elkészítés során törekedtem arra hogy minél könnyebb legyen használni az oldalt, azaz elég visszajelzést adjon és egyértelmű legyen minden. Az oldalak közötti navigáció és a </a:t>
+            </a:r>
+            <a:r>
+              <a:rPr lang="hu-HU" dirty="0" err="1"/>
+              <a:t>route</a:t>
+            </a:r>
+            <a:r>
+              <a:rPr lang="hu-HU" dirty="0"/>
+              <a:t> védelem szintén hozzám tartozott, illetve a backenddel való összekötés, az onnan küldött adatok megjelenítése, grafikonok megjelenítése és az adatainak betöltése. A különböző hibákat szintén én irattam ki, és persze a frontend tesztelése is az én feladatom volt.</a:t>
             </a:r>
           </a:p>
           <a:p>
@@ -2316,7 +2743,7 @@
           <a:p>
             <a:r>
               <a:rPr lang="hu-HU" dirty="0"/>
-              <a:t>A sima felhasználó hozzáfér a weboldal összes funkciójához a moderátor és az </a:t>
+              <a:t>Aki meglátogatja az oldalt az sima felhasználó, hozzáfér a weboldal összes funkciójához a moderátor és az </a:t>
             </a:r>
             <a:r>
               <a:rPr lang="hu-HU" dirty="0" err="1"/>
@@ -2324,7 +2751,7 @@
             </a:r>
             <a:r>
               <a:rPr lang="hu-HU" dirty="0"/>
-              <a:t> műveleteken kívül. Többek között meg tudja nézni az oldalt, tud regisztrálni vagy bejelentkezni, tud lépegetni az oldalak között és minden egyéb funkciót elér. Ezeket a funkciókat egy későbbi diában fogom részletezni.</a:t>
+              <a:t> műveleteken kívül. Ezeket a funkciókat egy későbbi diában fogom részletezni.</a:t>
             </a:r>
           </a:p>
           <a:p>
@@ -5105,7 +5532,7 @@
           <a:p>
             <a:fld id="{F5F1901C-D33B-4565-A7E4-5DF903098DB6}" type="datetimeFigureOut">
               <a:rPr lang="hu-HU" smtClean="0"/>
-              <a:t>2026. 04. 16.</a:t>
+              <a:t>2026. 04. 23.</a:t>
             </a:fld>
             <a:endParaRPr lang="hu-HU"/>
           </a:p>
@@ -5273,7 +5700,7 @@
           <a:p>
             <a:fld id="{F5F1901C-D33B-4565-A7E4-5DF903098DB6}" type="datetimeFigureOut">
               <a:rPr lang="hu-HU" smtClean="0"/>
-              <a:t>2026. 04. 16.</a:t>
+              <a:t>2026. 04. 23.</a:t>
             </a:fld>
             <a:endParaRPr lang="hu-HU"/>
           </a:p>
@@ -5451,7 +5878,7 @@
           <a:p>
             <a:fld id="{F5F1901C-D33B-4565-A7E4-5DF903098DB6}" type="datetimeFigureOut">
               <a:rPr lang="hu-HU" smtClean="0"/>
-              <a:t>2026. 04. 16.</a:t>
+              <a:t>2026. 04. 23.</a:t>
             </a:fld>
             <a:endParaRPr lang="hu-HU"/>
           </a:p>
@@ -5619,7 +6046,7 @@
           <a:p>
             <a:fld id="{F5F1901C-D33B-4565-A7E4-5DF903098DB6}" type="datetimeFigureOut">
               <a:rPr lang="hu-HU" smtClean="0"/>
-              <a:t>2026. 04. 16.</a:t>
+              <a:t>2026. 04. 23.</a:t>
             </a:fld>
             <a:endParaRPr lang="hu-HU"/>
           </a:p>
@@ -5864,7 +6291,7 @@
           <a:p>
             <a:fld id="{F5F1901C-D33B-4565-A7E4-5DF903098DB6}" type="datetimeFigureOut">
               <a:rPr lang="hu-HU" smtClean="0"/>
-              <a:t>2026. 04. 16.</a:t>
+              <a:t>2026. 04. 23.</a:t>
             </a:fld>
             <a:endParaRPr lang="hu-HU"/>
           </a:p>
@@ -6093,7 +6520,7 @@
           <a:p>
             <a:fld id="{F5F1901C-D33B-4565-A7E4-5DF903098DB6}" type="datetimeFigureOut">
               <a:rPr lang="hu-HU" smtClean="0"/>
-              <a:t>2026. 04. 16.</a:t>
+              <a:t>2026. 04. 23.</a:t>
             </a:fld>
             <a:endParaRPr lang="hu-HU"/>
           </a:p>
@@ -6457,7 +6884,7 @@
           <a:p>
             <a:fld id="{F5F1901C-D33B-4565-A7E4-5DF903098DB6}" type="datetimeFigureOut">
               <a:rPr lang="hu-HU" smtClean="0"/>
-              <a:t>2026. 04. 16.</a:t>
+              <a:t>2026. 04. 23.</a:t>
             </a:fld>
             <a:endParaRPr lang="hu-HU"/>
           </a:p>
@@ -6574,7 +7001,7 @@
           <a:p>
             <a:fld id="{F5F1901C-D33B-4565-A7E4-5DF903098DB6}" type="datetimeFigureOut">
               <a:rPr lang="hu-HU" smtClean="0"/>
-              <a:t>2026. 04. 16.</a:t>
+              <a:t>2026. 04. 23.</a:t>
             </a:fld>
             <a:endParaRPr lang="hu-HU"/>
           </a:p>
@@ -6669,7 +7096,7 @@
           <a:p>
             <a:fld id="{F5F1901C-D33B-4565-A7E4-5DF903098DB6}" type="datetimeFigureOut">
               <a:rPr lang="hu-HU" smtClean="0"/>
-              <a:t>2026. 04. 16.</a:t>
+              <a:t>2026. 04. 23.</a:t>
             </a:fld>
             <a:endParaRPr lang="hu-HU"/>
           </a:p>
@@ -6944,7 +7371,7 @@
           <a:p>
             <a:fld id="{F5F1901C-D33B-4565-A7E4-5DF903098DB6}" type="datetimeFigureOut">
               <a:rPr lang="hu-HU" smtClean="0"/>
-              <a:t>2026. 04. 16.</a:t>
+              <a:t>2026. 04. 23.</a:t>
             </a:fld>
             <a:endParaRPr lang="hu-HU"/>
           </a:p>
@@ -7196,7 +7623,7 @@
           <a:p>
             <a:fld id="{F5F1901C-D33B-4565-A7E4-5DF903098DB6}" type="datetimeFigureOut">
               <a:rPr lang="hu-HU" smtClean="0"/>
-              <a:t>2026. 04. 16.</a:t>
+              <a:t>2026. 04. 23.</a:t>
             </a:fld>
             <a:endParaRPr lang="hu-HU"/>
           </a:p>
@@ -7407,7 +7834,7 @@
           <a:p>
             <a:fld id="{F5F1901C-D33B-4565-A7E4-5DF903098DB6}" type="datetimeFigureOut">
               <a:rPr lang="hu-HU" smtClean="0"/>
-              <a:t>2026. 04. 16.</a:t>
+              <a:t>2026. 04. 23.</a:t>
             </a:fld>
             <a:endParaRPr lang="hu-HU"/>
           </a:p>
@@ -19387,7 +19814,7 @@
               </a:spcAft>
             </a:pPr>
             <a:r>
-              <a:rPr lang="hu-HU" sz="2000" b="1">
+              <a:rPr lang="hu-HU" sz="2000" b="1" dirty="0">
                 <a:solidFill>
                   <a:srgbClr val="94C6FF"/>
                 </a:solidFill>
@@ -19396,7 +19823,7 @@
               </a:rPr>
               <a:t>Főoldal megtekintése</a:t>
             </a:r>
-            <a:endParaRPr lang="hu-HU"/>
+            <a:endParaRPr lang="hu-HU" dirty="0"/>
           </a:p>
           <a:p>
             <a:pPr algn="ctr">
@@ -19405,7 +19832,7 @@
               </a:spcAft>
             </a:pPr>
             <a:r>
-              <a:rPr lang="hu-HU" sz="2000" b="1">
+              <a:rPr lang="hu-HU" sz="2000" b="1" dirty="0">
                 <a:solidFill>
                   <a:srgbClr val="94C6FF"/>
                 </a:solidFill>
@@ -19422,7 +19849,7 @@
               </a:spcAft>
             </a:pPr>
             <a:r>
-              <a:rPr lang="hu-HU" sz="2000" b="1">
+              <a:rPr lang="hu-HU" sz="2000" b="1" dirty="0">
                 <a:solidFill>
                   <a:srgbClr val="94C6FF"/>
                 </a:solidFill>
@@ -19439,7 +19866,7 @@
               </a:spcAft>
             </a:pPr>
             <a:r>
-              <a:rPr lang="hu-HU" sz="2000" b="1">
+              <a:rPr lang="hu-HU" sz="2000" b="1" dirty="0">
                 <a:solidFill>
                   <a:srgbClr val="94C6FF"/>
                 </a:solidFill>
@@ -19456,7 +19883,7 @@
               </a:spcAft>
             </a:pPr>
             <a:r>
-              <a:rPr lang="hu-HU" sz="2000" b="1">
+              <a:rPr lang="hu-HU" sz="2000" b="1" dirty="0">
                 <a:solidFill>
                   <a:srgbClr val="94C6FF"/>
                 </a:solidFill>
@@ -23482,6 +23909,52 @@
           <a:p>
             <a:pPr algn="ctr"/>
             <a:endParaRPr lang="hu-HU"/>
+          </a:p>
+        </p:txBody>
+      </p:sp>
+      <p:sp>
+        <p:nvSpPr>
+          <p:cNvPr id="24" name="Szövegdoboz 23">
+            <a:extLst>
+              <a:ext uri="{FF2B5EF4-FFF2-40B4-BE49-F238E27FC236}">
+                <a16:creationId xmlns:a16="http://schemas.microsoft.com/office/drawing/2014/main" id="{3E017674-CA11-9DE7-51A6-B48E775E5BCB}"/>
+              </a:ext>
+            </a:extLst>
+          </p:cNvPr>
+          <p:cNvSpPr txBox="1"/>
+          <p:nvPr/>
+        </p:nvSpPr>
+        <p:spPr>
+          <a:xfrm>
+            <a:off x="6143059" y="3964480"/>
+            <a:ext cx="5563742" cy="400110"/>
+          </a:xfrm>
+          <a:prstGeom prst="rect">
+            <a:avLst/>
+          </a:prstGeom>
+          <a:noFill/>
+        </p:spPr>
+        <p:txBody>
+          <a:bodyPr rot="0" spcFirstLastPara="0" vertOverflow="overflow" horzOverflow="overflow" vert="horz" wrap="square" lIns="91440" tIns="45720" rIns="91440" bIns="45720" numCol="1" spcCol="0" rtlCol="0" fromWordArt="0" anchor="t" anchorCtr="0" forceAA="0" compatLnSpc="1">
+            <a:prstTxWarp prst="textNoShape">
+              <a:avLst/>
+            </a:prstTxWarp>
+            <a:spAutoFit/>
+          </a:bodyPr>
+          <a:lstStyle/>
+          <a:p>
+            <a:pPr algn="ctr"/>
+            <a:r>
+              <a:rPr lang="hu-HU" sz="2000" b="1" dirty="0">
+                <a:solidFill>
+                  <a:srgbClr val="94C6FF"/>
+                </a:solidFill>
+                <a:latin typeface="Segoe UI"/>
+                <a:cs typeface="Segoe UI"/>
+              </a:rPr>
+              <a:t>XAMPP</a:t>
+            </a:r>
+            <a:endParaRPr lang="hu-HU" dirty="0"/>
           </a:p>
         </p:txBody>
       </p:sp>

</xml_diff>